<commit_message>
feat: designate YashRaj-Kushwaha as author and team as contributors across app, docs & presentation
</commit_message>
<xml_diff>
--- a/D43M0N$_CYBERSECURITY_ScamShield_AI.pptx
+++ b/D43M0N$_CYBERSECURITY_ScamShield_AI.pptx
@@ -3648,7 +3648,7 @@
               <a:spcBef>
                 <a:spcPts val="400"/>
               </a:spcBef>
-              <a:defRPr sz="1150" b="1">
+              <a:defRPr sz="1050" b="1">
                 <a:solidFill>
                   <a:srgbClr val="F8FAFC"/>
                 </a:solidFill>
@@ -3656,7 +3656,7 @@
               </a:defRPr>
             </a:pPr>
             <a:r>
-              <a:t>Mangal Nath Yadav (26BHI10047)   •   Aastik Tripathi (26BCY10090)   •   Yash Raj Kushwaha (26BCE10122)   •   Palak Kalra (26BCY10001)</a:t>
+              <a:t>👑 Author: Yash Raj Kushwaha (26BCE10122)   •   Contributors: Aastik Tripathi (26BCY10090)  •  Mangal Nath Yadav (26BHI10047)  •  Palak Kalra (26BCY10001)</a:t>
             </a:r>
           </a:p>
           <a:p>
@@ -4114,7 +4114,7 @@
               </a:defRPr>
             </a:pPr>
             <a:r>
-              <a:t>👥 Team D43M0N$ — Roster &amp; Project Links</a:t>
+              <a:t>👥 Author &amp; Contributors — Team D43M0N$</a:t>
             </a:r>
           </a:p>
           <a:p>
@@ -4130,7 +4130,7 @@
               </a:defRPr>
             </a:pPr>
             <a:r>
-              <a:t>▸ Mangal Nath Yadav</a:t>
+              <a:t>▸ 👑 Yash Raj Kushwaha (Author &amp; Lead)</a:t>
             </a:r>
           </a:p>
           <a:p>
@@ -4146,7 +4146,7 @@
               </a:defRPr>
             </a:pPr>
             <a:r>
-              <a:t>Reg No: 26BHI10047 · VIT Bhopal University</a:t>
+              <a:t>github.com/YashRaj-Kushwaha · Reg: 26BCE10122 · Architecture &amp; Full-Stack</a:t>
             </a:r>
           </a:p>
           <a:p>
@@ -4162,7 +4162,7 @@
               </a:defRPr>
             </a:pPr>
             <a:r>
-              <a:t>▸ Aastik Tripathi</a:t>
+              <a:t>▸ 🛡️ Aastik Tripathi (Contributor)</a:t>
             </a:r>
           </a:p>
           <a:p>
@@ -4178,7 +4178,7 @@
               </a:defRPr>
             </a:pPr>
             <a:r>
-              <a:t>Reg No: 26BCY10090 · VIT Bhopal University</a:t>
+              <a:t>github.com/DarkDevil811 · Reg: 26BCY10090 · Security &amp; Threat Scoring</a:t>
             </a:r>
           </a:p>
           <a:p>
@@ -4194,7 +4194,7 @@
               </a:defRPr>
             </a:pPr>
             <a:r>
-              <a:t>▸ Yash Raj Kushwaha</a:t>
+              <a:t>▸ 🔍 Mangal Nath Yadav (Contributor)</a:t>
             </a:r>
           </a:p>
           <a:p>
@@ -4210,7 +4210,7 @@
               </a:defRPr>
             </a:pPr>
             <a:r>
-              <a:t>Reg No: 26BCE10122 · VIT Bhopal University</a:t>
+              <a:t>github.com/shadowXg · Reg: 26BHI10047 · UPI &amp; QR Protocol Parsing</a:t>
             </a:r>
           </a:p>
           <a:p>
@@ -4226,7 +4226,7 @@
               </a:defRPr>
             </a:pPr>
             <a:r>
-              <a:t>▸ Palak Kalra</a:t>
+              <a:t>▸ ⚖️ Palak Kalra (Contributor)</a:t>
             </a:r>
           </a:p>
           <a:p>
@@ -4242,7 +4242,7 @@
               </a:defRPr>
             </a:pPr>
             <a:r>
-              <a:t>Reg No: 26BCY10001 · VIT Bhopal University</a:t>
+              <a:t>github.com/palak-kalra-gtihub · Reg: 26BCY10001 · Multilingual NLP &amp; Intelligence</a:t>
             </a:r>
           </a:p>
           <a:p>

</xml_diff>